<commit_message>
Add dashboard-usage slide and reframe architecture as end-to-end workflow
Deck is now 8 slides. New slide 6 covers how the dashboard is used
(evaluating tradeoffs, prioritizing against constraints, value delivered).
Former slide 6 becomes slide 7, retitled as the workflow from ingestion to
output with an explicit left-to-right step ribbon; reusability moves to 8.

Co-Authored-By: Claude Opus 5 (1M context) <noreply@anthropic.com>
Claude-Session: https://claude.ai/code/session_01WS81jGLE1ez25rpJRqf1oW
</commit_message>
<xml_diff>
--- a/deck/transformation-roadmap-generator.pptx
+++ b/deck/transformation-roadmap-generator.pptx
@@ -12,6 +12,7 @@
     <p:sldId id="260" r:id="rId11"/>
     <p:sldId id="261" r:id="rId12"/>
     <p:sldId id="262" r:id="rId13"/>
+    <p:sldId id="263" r:id="rId14"/>
   </p:sldIdLst>
   <p:sldSz cx="12191695" cy="6858000" type="screen4x3"/>
   <p:notesSz cx="6858000" cy="9144000"/>
@@ -9705,7 +9706,7 @@
                 </a:solidFill>
                 <a:latin typeface="Calibri"/>
               </a:rPr>
-              <a:t>ARCHITECTURE</a:t>
+              <a:t>USING THE TOOL</a:t>
             </a:r>
           </a:p>
         </p:txBody>
@@ -9739,7 +9740,7 @@
                 </a:solidFill>
                 <a:latin typeface="Calibri"/>
               </a:rPr>
-              <a:t>How it works: AI at ingest, deterministic code at decision time</a:t>
+              <a:t>How the dashboard is used</a:t>
             </a:r>
           </a:p>
         </p:txBody>
@@ -9773,7 +9774,7 @@
                 </a:solidFill>
                 <a:latin typeface="Calibri"/>
               </a:rPr>
-              <a:t>Re-run it and a judge gets the same answer, every time.</a:t>
+              <a:t>Three things a Chief Transformation Officer does with it in a single sitting.</a:t>
             </a:r>
           </a:p>
         </p:txBody>
@@ -9830,8 +9831,8 @@
         </p:nvSpPr>
         <p:spPr>
           <a:xfrm>
-            <a:off x="502920" y="1828800"/>
-            <a:ext cx="2487168" cy="2139696"/>
+            <a:off x="502920" y="1536192"/>
+            <a:ext cx="3675887" cy="2999232"/>
           </a:xfrm>
           <a:prstGeom prst="rect">
             <a:avLst/>
@@ -9870,150 +9871,16 @@
       </p:sp>
       <p:sp>
         <p:nvSpPr>
-          <p:cNvPr id="7" name="TextBox 6"/>
-          <p:cNvSpPr txBox="1"/>
-          <p:nvPr/>
-        </p:nvSpPr>
-        <p:spPr>
-          <a:xfrm>
-            <a:off x="630936" y="1975104"/>
-            <a:ext cx="2231136" cy="1883663"/>
-          </a:xfrm>
-          <a:prstGeom prst="rect">
-            <a:avLst/>
-          </a:prstGeom>
-          <a:noFill/>
-        </p:spPr>
-        <p:txBody>
-          <a:bodyPr wrap="square" lIns="0" rIns="0" tIns="0" bIns="0" anchor="t">
-            <a:spAutoFit/>
-          </a:bodyPr>
-          <a:lstStyle/>
-          <a:p>
-            <a:pPr>
-              <a:spcAft>
-                <a:spcPts val="500"/>
-              </a:spcAft>
-            </a:pPr>
-            <a:r>
-              <a:rPr sz="1250" b="1">
-                <a:solidFill>
-                  <a:srgbClr val="1B6E8C"/>
-                </a:solidFill>
-                <a:latin typeface="Calibri"/>
-              </a:rPr>
-              <a:t>1.  WHAT EXISTS TODAY</a:t>
-            </a:r>
-          </a:p>
-          <a:p>
-            <a:pPr>
-              <a:lnSpc>
-                <a:spcPct val="95000"/>
-              </a:lnSpc>
-              <a:spcAft>
-                <a:spcPts val="200"/>
-              </a:spcAft>
-            </a:pPr>
-            <a:r>
-              <a:rPr sz="1050">
-                <a:solidFill>
-                  <a:srgbClr val="333F4F"/>
-                </a:solidFill>
-                <a:latin typeface="Calibri"/>
-              </a:rPr>
-              <a:t>9 CSV extracts</a:t>
-            </a:r>
-          </a:p>
-          <a:p>
-            <a:pPr>
-              <a:lnSpc>
-                <a:spcPct val="95000"/>
-              </a:lnSpc>
-              <a:spcAft>
-                <a:spcPts val="200"/>
-              </a:spcAft>
-            </a:pPr>
-            <a:r>
-              <a:rPr sz="1050">
-                <a:solidFill>
-                  <a:srgbClr val="333F4F"/>
-                </a:solidFill>
-                <a:latin typeface="Calibri"/>
-              </a:rPr>
-              <a:t>Prose business cases</a:t>
-            </a:r>
-          </a:p>
-          <a:p>
-            <a:pPr>
-              <a:lnSpc>
-                <a:spcPct val="95000"/>
-              </a:lnSpc>
-              <a:spcAft>
-                <a:spcPts val="200"/>
-              </a:spcAft>
-            </a:pPr>
-            <a:r>
-              <a:rPr sz="1050">
-                <a:solidFill>
-                  <a:srgbClr val="333F4F"/>
-                </a:solidFill>
-                <a:latin typeface="Calibri"/>
-              </a:rPr>
-              <a:t>PMO status reports</a:t>
-            </a:r>
-          </a:p>
-          <a:p>
-            <a:pPr>
-              <a:lnSpc>
-                <a:spcPct val="95000"/>
-              </a:lnSpc>
-              <a:spcAft>
-                <a:spcPts val="200"/>
-              </a:spcAft>
-            </a:pPr>
-            <a:r>
-              <a:rPr sz="1050">
-                <a:solidFill>
-                  <a:srgbClr val="333F4F"/>
-                </a:solidFill>
-                <a:latin typeface="Calibri"/>
-              </a:rPr>
-              <a:t>Steering minutes</a:t>
-            </a:r>
-          </a:p>
-          <a:p>
-            <a:pPr>
-              <a:lnSpc>
-                <a:spcPct val="95000"/>
-              </a:lnSpc>
-              <a:spcAft>
-                <a:spcPts val="200"/>
-              </a:spcAft>
-            </a:pPr>
-            <a:r>
-              <a:rPr sz="1050">
-                <a:solidFill>
-                  <a:srgbClr val="333F4F"/>
-                </a:solidFill>
-                <a:latin typeface="Calibri"/>
-              </a:rPr>
-              <a:t>A messy master tracker</a:t>
-            </a:r>
-          </a:p>
-        </p:txBody>
-      </p:sp>
-      <p:sp>
-        <p:nvSpPr>
-          <p:cNvPr id="8" name="Right Arrow 7"/>
+          <p:cNvPr id="7" name="Rectangle 6"/>
           <p:cNvSpPr/>
           <p:nvPr/>
         </p:nvSpPr>
         <p:spPr>
           <a:xfrm>
-            <a:off x="3081528" y="2743200"/>
-            <a:ext cx="402336" cy="310896"/>
-          </a:xfrm>
-          <a:prstGeom prst="rightArrow">
+            <a:off x="502920" y="1536192"/>
+            <a:ext cx="57150" cy="2999232"/>
+          </a:xfrm>
+          <a:prstGeom prst="rect">
             <a:avLst/>
           </a:prstGeom>
           <a:solidFill>
@@ -10048,14 +9915,246 @@
       </p:sp>
       <p:sp>
         <p:nvSpPr>
+          <p:cNvPr id="8" name="TextBox 7"/>
+          <p:cNvSpPr txBox="1"/>
+          <p:nvPr/>
+        </p:nvSpPr>
+        <p:spPr>
+          <a:xfrm>
+            <a:off x="685800" y="1664207"/>
+            <a:ext cx="3328415" cy="2779776"/>
+          </a:xfrm>
+          <a:prstGeom prst="rect">
+            <a:avLst/>
+          </a:prstGeom>
+          <a:noFill/>
+        </p:spPr>
+        <p:txBody>
+          <a:bodyPr wrap="square" lIns="0" rIns="0" tIns="0" bIns="0" anchor="t">
+            <a:spAutoFit/>
+          </a:bodyPr>
+          <a:lstStyle/>
+          <a:p>
+            <a:pPr>
+              <a:spcAft>
+                <a:spcPts val="700"/>
+              </a:spcAft>
+            </a:pPr>
+            <a:r>
+              <a:rPr sz="1400" b="1">
+                <a:solidFill>
+                  <a:srgbClr val="1B6E8C"/>
+                </a:solidFill>
+                <a:latin typeface="Calibri"/>
+              </a:rPr>
+              <a:t>1.  EVALUATING TRADEOFFS</a:t>
+            </a:r>
+          </a:p>
+          <a:p>
+            <a:pPr marL="182880" indent="-182880">
+              <a:lnSpc>
+                <a:spcPct val="96000"/>
+              </a:lnSpc>
+              <a:spcAft>
+                <a:spcPts val="600"/>
+              </a:spcAft>
+            </a:pPr>
+            <a:r>
+              <a:rPr sz="1250" b="0">
+                <a:solidFill>
+                  <a:srgbClr val="333F4F"/>
+                </a:solidFill>
+                <a:latin typeface="Calibri"/>
+              </a:rPr>
+              <a:t>•  Switch between </a:t>
+            </a:r>
+            <a:r>
+              <a:rPr sz="1250" b="1">
+                <a:solidFill>
+                  <a:srgbClr val="16283C"/>
+                </a:solidFill>
+                <a:latin typeface="Calibri"/>
+              </a:rPr>
+              <a:t>board scenarios</a:t>
+            </a:r>
+            <a:r>
+              <a:rPr sz="1250" b="0">
+                <a:solidFill>
+                  <a:srgbClr val="333F4F"/>
+                </a:solidFill>
+                <a:latin typeface="Calibri"/>
+              </a:rPr>
+              <a:t> with one control</a:t>
+            </a:r>
+          </a:p>
+          <a:p>
+            <a:pPr marL="182880" indent="-182880">
+              <a:lnSpc>
+                <a:spcPct val="96000"/>
+              </a:lnSpc>
+              <a:spcAft>
+                <a:spcPts val="600"/>
+              </a:spcAft>
+            </a:pPr>
+            <a:r>
+              <a:rPr sz="1250" b="0">
+                <a:solidFill>
+                  <a:srgbClr val="333F4F"/>
+                </a:solidFill>
+                <a:latin typeface="Calibri"/>
+              </a:rPr>
+              <a:t>•  The </a:t>
+            </a:r>
+            <a:r>
+              <a:rPr sz="1250" b="1">
+                <a:solidFill>
+                  <a:srgbClr val="16283C"/>
+                </a:solidFill>
+                <a:latin typeface="Calibri"/>
+              </a:rPr>
+              <a:t>sequence</a:t>
+            </a:r>
+            <a:r>
+              <a:rPr sz="1250" b="0">
+                <a:solidFill>
+                  <a:srgbClr val="333F4F"/>
+                </a:solidFill>
+                <a:latin typeface="Calibri"/>
+              </a:rPr>
+              <a:t>, the </a:t>
+            </a:r>
+            <a:r>
+              <a:rPr sz="1250" b="1">
+                <a:solidFill>
+                  <a:srgbClr val="16283C"/>
+                </a:solidFill>
+                <a:latin typeface="Calibri"/>
+              </a:rPr>
+              <a:t>conflicts</a:t>
+            </a:r>
+            <a:r>
+              <a:rPr sz="1250" b="0">
+                <a:solidFill>
+                  <a:srgbClr val="333F4F"/>
+                </a:solidFill>
+                <a:latin typeface="Calibri"/>
+              </a:rPr>
+              <a:t> and the </a:t>
+            </a:r>
+            <a:r>
+              <a:rPr sz="1250" b="1">
+                <a:solidFill>
+                  <a:srgbClr val="16283C"/>
+                </a:solidFill>
+                <a:latin typeface="Calibri"/>
+              </a:rPr>
+              <a:t>benefit curve</a:t>
+            </a:r>
+            <a:r>
+              <a:rPr sz="1250" b="0">
+                <a:solidFill>
+                  <a:srgbClr val="333F4F"/>
+                </a:solidFill>
+                <a:latin typeface="Calibri"/>
+              </a:rPr>
+              <a:t> all move together, side by side</a:t>
+            </a:r>
+          </a:p>
+          <a:p>
+            <a:pPr marL="182880" indent="-182880">
+              <a:lnSpc>
+                <a:spcPct val="96000"/>
+              </a:lnSpc>
+              <a:spcAft>
+                <a:spcPts val="600"/>
+              </a:spcAft>
+            </a:pPr>
+            <a:r>
+              <a:rPr sz="1250" b="0">
+                <a:solidFill>
+                  <a:srgbClr val="333F4F"/>
+                </a:solidFill>
+                <a:latin typeface="Calibri"/>
+              </a:rPr>
+              <a:t>•  Compare </a:t>
+            </a:r>
+            <a:r>
+              <a:rPr sz="1250" b="1">
+                <a:solidFill>
+                  <a:srgbClr val="16283C"/>
+                </a:solidFill>
+                <a:latin typeface="Calibri"/>
+              </a:rPr>
+              <a:t>"fastest value"</a:t>
+            </a:r>
+            <a:r>
+              <a:rPr sz="1250" b="0">
+                <a:solidFill>
+                  <a:srgbClr val="333F4F"/>
+                </a:solidFill>
+                <a:latin typeface="Calibri"/>
+              </a:rPr>
+              <a:t> against </a:t>
+            </a:r>
+            <a:r>
+              <a:rPr sz="1250" b="1">
+                <a:solidFill>
+                  <a:srgbClr val="16283C"/>
+                </a:solidFill>
+                <a:latin typeface="Calibri"/>
+              </a:rPr>
+              <a:t>"lowest risk"</a:t>
+            </a:r>
+            <a:r>
+              <a:rPr sz="1250" b="0">
+                <a:solidFill>
+                  <a:srgbClr val="333F4F"/>
+                </a:solidFill>
+                <a:latin typeface="Calibri"/>
+              </a:rPr>
+              <a:t> on screen</a:t>
+            </a:r>
+          </a:p>
+          <a:p>
+            <a:pPr marL="182880" indent="-182880">
+              <a:lnSpc>
+                <a:spcPct val="96000"/>
+              </a:lnSpc>
+              <a:spcAft>
+                <a:spcPts val="600"/>
+              </a:spcAft>
+            </a:pPr>
+            <a:r>
+              <a:rPr sz="1250" b="0">
+                <a:solidFill>
+                  <a:srgbClr val="333F4F"/>
+                </a:solidFill>
+                <a:latin typeface="Calibri"/>
+              </a:rPr>
+              <a:t>•  The choice gets </a:t>
+            </a:r>
+            <a:r>
+              <a:rPr sz="1250" b="1">
+                <a:solidFill>
+                  <a:srgbClr val="16283C"/>
+                </a:solidFill>
+                <a:latin typeface="Calibri"/>
+              </a:rPr>
+              <a:t>compared, not argued about</a:t>
+            </a:r>
+          </a:p>
+        </p:txBody>
+      </p:sp>
+      <p:sp>
+        <p:nvSpPr>
           <p:cNvPr id="9" name="Rectangle 8"/>
           <p:cNvSpPr/>
           <p:nvPr/>
         </p:nvSpPr>
         <p:spPr>
           <a:xfrm>
-            <a:off x="3401568" y="1828800"/>
-            <a:ext cx="2487168" cy="2139696"/>
+            <a:off x="4261104" y="1536192"/>
+            <a:ext cx="3675887" cy="2999232"/>
           </a:xfrm>
           <a:prstGeom prst="rect">
             <a:avLst/>
@@ -10094,150 +10193,16 @@
       </p:sp>
       <p:sp>
         <p:nvSpPr>
-          <p:cNvPr id="10" name="TextBox 9"/>
-          <p:cNvSpPr txBox="1"/>
-          <p:nvPr/>
-        </p:nvSpPr>
-        <p:spPr>
-          <a:xfrm>
-            <a:off x="3529584" y="1975104"/>
-            <a:ext cx="2231136" cy="1883663"/>
-          </a:xfrm>
-          <a:prstGeom prst="rect">
-            <a:avLst/>
-          </a:prstGeom>
-          <a:noFill/>
-        </p:spPr>
-        <p:txBody>
-          <a:bodyPr wrap="square" lIns="0" rIns="0" tIns="0" bIns="0" anchor="t">
-            <a:spAutoFit/>
-          </a:bodyPr>
-          <a:lstStyle/>
-          <a:p>
-            <a:pPr>
-              <a:spcAft>
-                <a:spcPts val="500"/>
-              </a:spcAft>
-            </a:pPr>
-            <a:r>
-              <a:rPr sz="1250" b="1">
-                <a:solidFill>
-                  <a:srgbClr val="1B6E8C"/>
-                </a:solidFill>
-                <a:latin typeface="Calibri"/>
-              </a:rPr>
-              <a:t>2.  OFFLINE INGEST</a:t>
-            </a:r>
-          </a:p>
-          <a:p>
-            <a:pPr>
-              <a:lnSpc>
-                <a:spcPct val="95000"/>
-              </a:lnSpc>
-              <a:spcAft>
-                <a:spcPts val="200"/>
-              </a:spcAft>
-            </a:pPr>
-            <a:r>
-              <a:rPr sz="1050">
-                <a:solidFill>
-                  <a:srgbClr val="333F4F"/>
-                </a:solidFill>
-                <a:latin typeface="Calibri"/>
-              </a:rPr>
-              <a:t>AI extraction of structured</a:t>
-            </a:r>
-          </a:p>
-          <a:p>
-            <a:pPr>
-              <a:lnSpc>
-                <a:spcPct val="95000"/>
-              </a:lnSpc>
-              <a:spcAft>
-                <a:spcPts val="200"/>
-              </a:spcAft>
-            </a:pPr>
-            <a:r>
-              <a:rPr sz="1050">
-                <a:solidFill>
-                  <a:srgbClr val="333F4F"/>
-                </a:solidFill>
-                <a:latin typeface="Calibri"/>
-              </a:rPr>
-              <a:t>fields from prose</a:t>
-            </a:r>
-          </a:p>
-          <a:p>
-            <a:pPr>
-              <a:lnSpc>
-                <a:spcPct val="95000"/>
-              </a:lnSpc>
-              <a:spcAft>
-                <a:spcPts val="200"/>
-              </a:spcAft>
-            </a:pPr>
-            <a:r>
-              <a:rPr sz="1050">
-                <a:solidFill>
-                  <a:srgbClr val="333F4F"/>
-                </a:solidFill>
-                <a:latin typeface="Calibri"/>
-              </a:rPr>
-              <a:t>+ normalization rules</a:t>
-            </a:r>
-          </a:p>
-          <a:p>
-            <a:pPr>
-              <a:lnSpc>
-                <a:spcPct val="95000"/>
-              </a:lnSpc>
-              <a:spcAft>
-                <a:spcPts val="200"/>
-              </a:spcAft>
-            </a:pPr>
-            <a:r>
-              <a:rPr sz="1050">
-                <a:solidFill>
-                  <a:srgbClr val="333F4F"/>
-                </a:solidFill>
-                <a:latin typeface="Calibri"/>
-              </a:rPr>
-              <a:t/>
-            </a:r>
-          </a:p>
-          <a:p>
-            <a:pPr>
-              <a:lnSpc>
-                <a:spcPct val="95000"/>
-              </a:lnSpc>
-              <a:spcAft>
-                <a:spcPts val="200"/>
-              </a:spcAft>
-            </a:pPr>
-            <a:r>
-              <a:rPr sz="1050">
-                <a:solidFill>
-                  <a:srgbClr val="333F4F"/>
-                </a:solidFill>
-                <a:latin typeface="Calibri"/>
-              </a:rPr>
-              <a:t>Run once, output committed</a:t>
-            </a:r>
-          </a:p>
-        </p:txBody>
-      </p:sp>
-      <p:sp>
-        <p:nvSpPr>
-          <p:cNvPr id="11" name="Right Arrow 10"/>
+          <p:cNvPr id="10" name="Rectangle 9"/>
           <p:cNvSpPr/>
           <p:nvPr/>
         </p:nvSpPr>
         <p:spPr>
           <a:xfrm>
-            <a:off x="5980176" y="2743200"/>
-            <a:ext cx="402336" cy="310896"/>
-          </a:xfrm>
-          <a:prstGeom prst="rightArrow">
+            <a:off x="4261104" y="1536192"/>
+            <a:ext cx="57150" cy="2999232"/>
+          </a:xfrm>
+          <a:prstGeom prst="rect">
             <a:avLst/>
           </a:prstGeom>
           <a:solidFill>
@@ -10272,14 +10237,432 @@
       </p:sp>
       <p:sp>
         <p:nvSpPr>
+          <p:cNvPr id="11" name="TextBox 10"/>
+          <p:cNvSpPr txBox="1"/>
+          <p:nvPr/>
+        </p:nvSpPr>
+        <p:spPr>
+          <a:xfrm>
+            <a:off x="4443984" y="1664207"/>
+            <a:ext cx="3328415" cy="2779776"/>
+          </a:xfrm>
+          <a:prstGeom prst="rect">
+            <a:avLst/>
+          </a:prstGeom>
+          <a:noFill/>
+        </p:spPr>
+        <p:txBody>
+          <a:bodyPr wrap="square" lIns="0" rIns="0" tIns="0" bIns="0" anchor="t">
+            <a:spAutoFit/>
+          </a:bodyPr>
+          <a:lstStyle/>
+          <a:p>
+            <a:pPr>
+              <a:spcAft>
+                <a:spcPts val="700"/>
+              </a:spcAft>
+            </a:pPr>
+            <a:r>
+              <a:rPr sz="1400" b="1">
+                <a:solidFill>
+                  <a:srgbClr val="1B6E8C"/>
+                </a:solidFill>
+                <a:latin typeface="Calibri"/>
+              </a:rPr>
+              <a:t>2.  PRIORITIZING AGAINST CONSTRAINTS</a:t>
+            </a:r>
+          </a:p>
+          <a:p>
+            <a:pPr marL="182880" indent="-182880">
+              <a:lnSpc>
+                <a:spcPct val="96000"/>
+              </a:lnSpc>
+              <a:spcAft>
+                <a:spcPts val="600"/>
+              </a:spcAft>
+            </a:pPr>
+            <a:r>
+              <a:rPr sz="1250" b="0">
+                <a:solidFill>
+                  <a:srgbClr val="333F4F"/>
+                </a:solidFill>
+                <a:latin typeface="Calibri"/>
+              </a:rPr>
+              <a:t>•  Sequences against the </a:t>
+            </a:r>
+            <a:r>
+              <a:rPr sz="1250" b="1">
+                <a:solidFill>
+                  <a:srgbClr val="16283C"/>
+                </a:solidFill>
+                <a:latin typeface="Calibri"/>
+              </a:rPr>
+              <a:t>real caps in the data</a:t>
+            </a:r>
+            <a:r>
+              <a:rPr sz="1250" b="0">
+                <a:solidFill>
+                  <a:srgbClr val="333F4F"/>
+                </a:solidFill>
+                <a:latin typeface="Calibri"/>
+              </a:rPr>
+              <a:t> — budget and capex caps, peak FTE caps, mandatory and deferred initiatives</a:t>
+            </a:r>
+          </a:p>
+          <a:p>
+            <a:pPr marL="182880" indent="-182880">
+              <a:lnSpc>
+                <a:spcPct val="96000"/>
+              </a:lnSpc>
+              <a:spcAft>
+                <a:spcPts val="600"/>
+              </a:spcAft>
+            </a:pPr>
+            <a:r>
+              <a:rPr sz="1250" b="0">
+                <a:solidFill>
+                  <a:srgbClr val="333F4F"/>
+                </a:solidFill>
+                <a:latin typeface="Calibri"/>
+              </a:rPr>
+              <a:t>•  Flags </a:t>
+            </a:r>
+            <a:r>
+              <a:rPr sz="1250" b="1">
+                <a:solidFill>
+                  <a:srgbClr val="16283C"/>
+                </a:solidFill>
+                <a:latin typeface="Calibri"/>
+              </a:rPr>
+              <a:t>4 violation types</a:t>
+            </a:r>
+            <a:r>
+              <a:rPr sz="1250" b="0">
+                <a:solidFill>
+                  <a:srgbClr val="333F4F"/>
+                </a:solidFill>
+                <a:latin typeface="Calibri"/>
+              </a:rPr>
+              <a:t>: dependency, resource, budget, compliance</a:t>
+            </a:r>
+          </a:p>
+          <a:p>
+            <a:pPr marL="182880" indent="-182880">
+              <a:lnSpc>
+                <a:spcPct val="96000"/>
+              </a:lnSpc>
+              <a:spcAft>
+                <a:spcPts val="600"/>
+              </a:spcAft>
+            </a:pPr>
+            <a:r>
+              <a:rPr sz="1250" b="0">
+                <a:solidFill>
+                  <a:srgbClr val="333F4F"/>
+                </a:solidFill>
+                <a:latin typeface="Calibri"/>
+              </a:rPr>
+              <a:t>•  </a:t>
+            </a:r>
+            <a:r>
+              <a:rPr sz="1250" b="1">
+                <a:solidFill>
+                  <a:srgbClr val="16283C"/>
+                </a:solidFill>
+                <a:latin typeface="Calibri"/>
+              </a:rPr>
+              <a:t>Compliance sorts to the top</a:t>
+            </a:r>
+            <a:r>
+              <a:rPr sz="1250" b="0">
+                <a:solidFill>
+                  <a:srgbClr val="333F4F"/>
+                </a:solidFill>
+                <a:latin typeface="Calibri"/>
+              </a:rPr>
+              <a:t> of the exception list</a:t>
+            </a:r>
+          </a:p>
+          <a:p>
+            <a:pPr marL="182880" indent="-182880">
+              <a:lnSpc>
+                <a:spcPct val="96000"/>
+              </a:lnSpc>
+              <a:spcAft>
+                <a:spcPts val="600"/>
+              </a:spcAft>
+            </a:pPr>
+            <a:r>
+              <a:rPr sz="1250" b="0">
+                <a:solidFill>
+                  <a:srgbClr val="333F4F"/>
+                </a:solidFill>
+                <a:latin typeface="Calibri"/>
+              </a:rPr>
+              <a:t>•  </a:t>
+            </a:r>
+            <a:r>
+              <a:rPr sz="1250" b="1">
+                <a:solidFill>
+                  <a:srgbClr val="16283C"/>
+                </a:solidFill>
+                <a:latin typeface="Calibri"/>
+              </a:rPr>
+              <a:t>Regulatory initiatives can never be deferred</a:t>
+            </a:r>
+            <a:r>
+              <a:rPr sz="1250" b="0">
+                <a:solidFill>
+                  <a:srgbClr val="333F4F"/>
+                </a:solidFill>
+                <a:latin typeface="Calibri"/>
+              </a:rPr>
+              <a:t> by a scenario</a:t>
+            </a:r>
+          </a:p>
+        </p:txBody>
+      </p:sp>
+      <p:sp>
+        <p:nvSpPr>
           <p:cNvPr id="12" name="Rectangle 11"/>
           <p:cNvSpPr/>
           <p:nvPr/>
         </p:nvSpPr>
         <p:spPr>
           <a:xfrm>
-            <a:off x="6300216" y="1828800"/>
-            <a:ext cx="2487168" cy="2139696"/>
+            <a:off x="8019288" y="1536192"/>
+            <a:ext cx="3666744" cy="2999232"/>
+          </a:xfrm>
+          <a:prstGeom prst="rect">
+            <a:avLst/>
+          </a:prstGeom>
+          <a:solidFill>
+            <a:srgbClr val="F4F6F8"/>
+          </a:solidFill>
+          <a:ln w="9525">
+            <a:solidFill>
+              <a:srgbClr val="D5DCE2"/>
+            </a:solidFill>
+          </a:ln>
+          <a:effectLst/>
+        </p:spPr>
+        <p:style>
+          <a:lnRef idx="1">
+            <a:schemeClr val="accent1"/>
+          </a:lnRef>
+          <a:fillRef idx="3">
+            <a:schemeClr val="accent1"/>
+          </a:fillRef>
+          <a:effectRef idx="2">
+            <a:schemeClr val="accent1"/>
+          </a:effectRef>
+          <a:fontRef idx="minor">
+            <a:schemeClr val="lt1"/>
+          </a:fontRef>
+        </p:style>
+        <p:txBody>
+          <a:bodyPr rtlCol="0" anchor="ctr"/>
+          <a:lstStyle/>
+          <a:p>
+            <a:pPr algn="ctr"/>
+          </a:p>
+        </p:txBody>
+      </p:sp>
+      <p:sp>
+        <p:nvSpPr>
+          <p:cNvPr id="13" name="Rectangle 12"/>
+          <p:cNvSpPr/>
+          <p:nvPr/>
+        </p:nvSpPr>
+        <p:spPr>
+          <a:xfrm>
+            <a:off x="8019288" y="1536192"/>
+            <a:ext cx="57150" cy="2999232"/>
+          </a:xfrm>
+          <a:prstGeom prst="rect">
+            <a:avLst/>
+          </a:prstGeom>
+          <a:solidFill>
+            <a:srgbClr val="16283C"/>
+          </a:solidFill>
+          <a:ln>
+            <a:noFill/>
+          </a:ln>
+          <a:effectLst/>
+        </p:spPr>
+        <p:style>
+          <a:lnRef idx="1">
+            <a:schemeClr val="accent1"/>
+          </a:lnRef>
+          <a:fillRef idx="3">
+            <a:schemeClr val="accent1"/>
+          </a:fillRef>
+          <a:effectRef idx="2">
+            <a:schemeClr val="accent1"/>
+          </a:effectRef>
+          <a:fontRef idx="minor">
+            <a:schemeClr val="lt1"/>
+          </a:fontRef>
+        </p:style>
+        <p:txBody>
+          <a:bodyPr rtlCol="0" anchor="ctr"/>
+          <a:lstStyle/>
+          <a:p>
+            <a:pPr algn="ctr"/>
+          </a:p>
+        </p:txBody>
+      </p:sp>
+      <p:sp>
+        <p:nvSpPr>
+          <p:cNvPr id="14" name="TextBox 13"/>
+          <p:cNvSpPr txBox="1"/>
+          <p:nvPr/>
+        </p:nvSpPr>
+        <p:spPr>
+          <a:xfrm>
+            <a:off x="8202167" y="1664207"/>
+            <a:ext cx="3319272" cy="2779776"/>
+          </a:xfrm>
+          <a:prstGeom prst="rect">
+            <a:avLst/>
+          </a:prstGeom>
+          <a:noFill/>
+        </p:spPr>
+        <p:txBody>
+          <a:bodyPr wrap="square" lIns="0" rIns="0" tIns="0" bIns="0" anchor="t">
+            <a:spAutoFit/>
+          </a:bodyPr>
+          <a:lstStyle/>
+          <a:p>
+            <a:pPr>
+              <a:spcAft>
+                <a:spcPts val="700"/>
+              </a:spcAft>
+            </a:pPr>
+            <a:r>
+              <a:rPr sz="1400" b="1">
+                <a:solidFill>
+                  <a:srgbClr val="16283C"/>
+                </a:solidFill>
+                <a:latin typeface="Calibri"/>
+              </a:rPr>
+              <a:t>3.  VALUE DELIVERED TO THE CLIENT</a:t>
+            </a:r>
+          </a:p>
+          <a:p>
+            <a:pPr marL="182880" indent="-182880">
+              <a:lnSpc>
+                <a:spcPct val="96000"/>
+              </a:lnSpc>
+              <a:spcAft>
+                <a:spcPts val="600"/>
+              </a:spcAft>
+            </a:pPr>
+            <a:r>
+              <a:rPr sz="1250" b="0">
+                <a:solidFill>
+                  <a:srgbClr val="333F4F"/>
+                </a:solidFill>
+                <a:latin typeface="Calibri"/>
+              </a:rPr>
+              <a:t>•  A </a:t>
+            </a:r>
+            <a:r>
+              <a:rPr sz="1250" b="1">
+                <a:solidFill>
+                  <a:srgbClr val="16283C"/>
+                </a:solidFill>
+                <a:latin typeface="Calibri"/>
+              </a:rPr>
+              <a:t>defensible sequencing decision in minutes</a:t>
+            </a:r>
+            <a:r>
+              <a:rPr sz="1250" b="0">
+                <a:solidFill>
+                  <a:srgbClr val="333F4F"/>
+                </a:solidFill>
+                <a:latin typeface="Calibri"/>
+              </a:rPr>
+              <a:t>, not weeks of PMO analysis</a:t>
+            </a:r>
+          </a:p>
+          <a:p>
+            <a:pPr marL="182880" indent="-182880">
+              <a:lnSpc>
+                <a:spcPct val="96000"/>
+              </a:lnSpc>
+              <a:spcAft>
+                <a:spcPts val="600"/>
+              </a:spcAft>
+            </a:pPr>
+            <a:r>
+              <a:rPr sz="1250" b="0">
+                <a:solidFill>
+                  <a:srgbClr val="333F4F"/>
+                </a:solidFill>
+                <a:latin typeface="Calibri"/>
+              </a:rPr>
+              <a:t>•  </a:t>
+            </a:r>
+            <a:r>
+              <a:rPr sz="1250" b="1">
+                <a:solidFill>
+                  <a:srgbClr val="16283C"/>
+                </a:solidFill>
+                <a:latin typeface="Calibri"/>
+              </a:rPr>
+              <a:t>Conflicts caught before money is committed</a:t>
+            </a:r>
+            <a:r>
+              <a:rPr sz="1250" b="0">
+                <a:solidFill>
+                  <a:srgbClr val="333F4F"/>
+                </a:solidFill>
+                <a:latin typeface="Calibri"/>
+              </a:rPr>
+              <a:t>, not after</a:t>
+            </a:r>
+          </a:p>
+          <a:p>
+            <a:pPr marL="182880" indent="-182880">
+              <a:lnSpc>
+                <a:spcPct val="96000"/>
+              </a:lnSpc>
+              <a:spcAft>
+                <a:spcPts val="600"/>
+              </a:spcAft>
+            </a:pPr>
+            <a:r>
+              <a:rPr sz="1250" b="0">
+                <a:solidFill>
+                  <a:srgbClr val="333F4F"/>
+                </a:solidFill>
+                <a:latin typeface="Calibri"/>
+              </a:rPr>
+              <a:t>•  A clear answer for the board on </a:t>
+            </a:r>
+            <a:r>
+              <a:rPr sz="1250" b="1">
+                <a:solidFill>
+                  <a:srgbClr val="16283C"/>
+                </a:solidFill>
+                <a:latin typeface="Calibri"/>
+              </a:rPr>
+              <a:t>when benefit reaches the P&amp;L</a:t>
+            </a:r>
+          </a:p>
+        </p:txBody>
+      </p:sp>
+      <p:sp>
+        <p:nvSpPr>
+          <p:cNvPr id="15" name="Rectangle 14"/>
+          <p:cNvSpPr/>
+          <p:nvPr/>
+        </p:nvSpPr>
+        <p:spPr>
+          <a:xfrm>
+            <a:off x="502920" y="4791456"/>
+            <a:ext cx="11183112" cy="1243584"/>
           </a:xfrm>
           <a:prstGeom prst="rect">
             <a:avLst/>
@@ -10318,14 +10701,14 @@
       </p:sp>
       <p:sp>
         <p:nvSpPr>
-          <p:cNvPr id="13" name="TextBox 12"/>
+          <p:cNvPr id="16" name="TextBox 15"/>
           <p:cNvSpPr txBox="1"/>
           <p:nvPr/>
         </p:nvSpPr>
         <p:spPr>
           <a:xfrm>
-            <a:off x="6428231" y="1975104"/>
-            <a:ext cx="2231136" cy="1883663"/>
+            <a:off x="731520" y="4974336"/>
+            <a:ext cx="10725912" cy="914400"/>
           </a:xfrm>
           <a:prstGeom prst="rect">
             <a:avLst/>
@@ -10339,148 +10722,185 @@
           <a:lstStyle/>
           <a:p>
             <a:pPr>
+              <a:lnSpc>
+                <a:spcPct val="98000"/>
+              </a:lnSpc>
               <a:spcAft>
                 <a:spcPts val="500"/>
               </a:spcAft>
             </a:pPr>
             <a:r>
-              <a:rPr sz="1250" b="1">
-                <a:solidFill>
-                  <a:srgbClr val="1B6E8C"/>
-                </a:solidFill>
-                <a:latin typeface="Calibri"/>
-              </a:rPr>
-              <a:t>3.  ONE DATA FILE</a:t>
+              <a:rPr sz="1300" b="1">
+                <a:solidFill>
+                  <a:srgbClr val="16283C"/>
+                </a:solidFill>
+                <a:latin typeface="Calibri"/>
+              </a:rPr>
+              <a:t>One screen, one owner, one monthly cycle.</a:t>
+            </a:r>
+            <a:r>
+              <a:rPr sz="1300" b="0">
+                <a:solidFill>
+                  <a:srgbClr val="333F4F"/>
+                </a:solidFill>
+                <a:latin typeface="Calibri"/>
+              </a:rPr>
+              <a:t> The CTO drives it in the board meeting; the PMO lead re-runs it on every status report.</a:t>
             </a:r>
           </a:p>
           <a:p>
             <a:pPr>
               <a:lnSpc>
-                <a:spcPct val="95000"/>
+                <a:spcPct val="98000"/>
               </a:lnSpc>
               <a:spcAft>
-                <a:spcPts val="200"/>
-              </a:spcAft>
-            </a:pPr>
-            <a:r>
-              <a:rPr sz="1050">
-                <a:solidFill>
-                  <a:srgbClr val="333F4F"/>
-                </a:solidFill>
-                <a:latin typeface="Calibri"/>
-              </a:rPr>
-              <a:t>A single committed</a:t>
-            </a:r>
-          </a:p>
-          <a:p>
-            <a:pPr>
-              <a:lnSpc>
-                <a:spcPct val="95000"/>
-              </a:lnSpc>
-              <a:spcAft>
-                <a:spcPts val="200"/>
-              </a:spcAft>
-            </a:pPr>
-            <a:r>
-              <a:rPr sz="1050">
-                <a:solidFill>
-                  <a:srgbClr val="333F4F"/>
-                </a:solidFill>
-                <a:latin typeface="Calibri"/>
-              </a:rPr>
-              <a:t>initiative model:</a:t>
-            </a:r>
-          </a:p>
-          <a:p>
-            <a:pPr>
-              <a:lnSpc>
-                <a:spcPct val="95000"/>
-              </a:lnSpc>
-              <a:spcAft>
-                <a:spcPts val="200"/>
-              </a:spcAft>
-            </a:pPr>
-            <a:r>
-              <a:rPr sz="1050">
-                <a:solidFill>
-                  <a:srgbClr val="333F4F"/>
-                </a:solidFill>
-                <a:latin typeface="Calibri"/>
-              </a:rPr>
-              <a:t>cost, dates, benefit,</a:t>
-            </a:r>
-          </a:p>
-          <a:p>
-            <a:pPr>
-              <a:lnSpc>
-                <a:spcPct val="95000"/>
-              </a:lnSpc>
-              <a:spcAft>
-                <a:spcPts val="200"/>
-              </a:spcAft>
-            </a:pPr>
-            <a:r>
-              <a:rPr sz="1050">
-                <a:solidFill>
-                  <a:srgbClr val="333F4F"/>
-                </a:solidFill>
-                <a:latin typeface="Calibri"/>
-              </a:rPr>
-              <a:t>dependencies, constraints</a:t>
-            </a:r>
-          </a:p>
-          <a:p>
-            <a:pPr>
-              <a:lnSpc>
-                <a:spcPct val="95000"/>
-              </a:lnSpc>
-              <a:spcAft>
-                <a:spcPts val="200"/>
-              </a:spcAft>
-            </a:pPr>
-            <a:r>
-              <a:rPr sz="1050">
-                <a:solidFill>
-                  <a:srgbClr val="333F4F"/>
-                </a:solidFill>
-                <a:latin typeface="Calibri"/>
-              </a:rPr>
-              <a:t/>
-            </a:r>
-          </a:p>
-          <a:p>
-            <a:pPr>
-              <a:lnSpc>
-                <a:spcPct val="95000"/>
-              </a:lnSpc>
-              <a:spcAft>
-                <a:spcPts val="200"/>
-              </a:spcAft>
-            </a:pPr>
-            <a:r>
-              <a:rPr sz="1050">
-                <a:solidFill>
-                  <a:srgbClr val="333F4F"/>
-                </a:solidFill>
-                <a:latin typeface="Calibri"/>
-              </a:rPr>
-              <a:t>The app's only input</a:t>
-            </a:r>
-          </a:p>
-        </p:txBody>
-      </p:sp>
-      <p:sp>
-        <p:nvSpPr>
-          <p:cNvPr id="14" name="Right Arrow 13"/>
+                <a:spcPts val="500"/>
+              </a:spcAft>
+            </a:pPr>
+            <a:r>
+              <a:rPr sz="1300" b="0">
+                <a:solidFill>
+                  <a:srgbClr val="333F4F"/>
+                </a:solidFill>
+                <a:latin typeface="Calibri"/>
+              </a:rPr>
+              <a:t>Nothing is hidden behind a model call — every ordering and every exception traces back to a row in the client's own data.</a:t>
+            </a:r>
+          </a:p>
+        </p:txBody>
+      </p:sp>
+    </p:spTree>
+  </p:cSld>
+  <p:clrMapOvr>
+    <a:masterClrMapping/>
+  </p:clrMapOvr>
+</p:sld>
+</file>
+
+<file path=ppt/slides/slide7.xml><?xml version="1.0" encoding="utf-8"?>
+<p:sld xmlns:a="http://schemas.openxmlformats.org/drawingml/2006/main" xmlns:p="http://schemas.openxmlformats.org/presentationml/2006/main" xmlns:r="http://schemas.openxmlformats.org/officeDocument/2006/relationships">
+  <p:cSld>
+    <p:spTree>
+      <p:nvGrpSpPr>
+        <p:cNvPr id="1" name=""/>
+        <p:cNvGrpSpPr/>
+        <p:nvPr/>
+      </p:nvGrpSpPr>
+      <p:grpSpPr/>
+      <p:sp>
+        <p:nvSpPr>
+          <p:cNvPr id="2" name="TextBox 1"/>
+          <p:cNvSpPr txBox="1"/>
+          <p:nvPr/>
+        </p:nvSpPr>
+        <p:spPr>
+          <a:xfrm>
+            <a:off x="502920" y="182880"/>
+            <a:ext cx="11183112" cy="237744"/>
+          </a:xfrm>
+          <a:prstGeom prst="rect">
+            <a:avLst/>
+          </a:prstGeom>
+          <a:noFill/>
+        </p:spPr>
+        <p:txBody>
+          <a:bodyPr wrap="square" lIns="0" rIns="0" tIns="0" bIns="0">
+            <a:spAutoFit/>
+          </a:bodyPr>
+          <a:lstStyle/>
+          <a:p>
+            <a:r>
+              <a:rPr sz="1100" b="1">
+                <a:solidFill>
+                  <a:srgbClr val="1B6E8C"/>
+                </a:solidFill>
+                <a:latin typeface="Calibri"/>
+              </a:rPr>
+              <a:t>WORKFLOW: INGESTION → OUTPUT</a:t>
+            </a:r>
+          </a:p>
+        </p:txBody>
+      </p:sp>
+      <p:sp>
+        <p:nvSpPr>
+          <p:cNvPr id="3" name="TextBox 2"/>
+          <p:cNvSpPr txBox="1"/>
+          <p:nvPr/>
+        </p:nvSpPr>
+        <p:spPr>
+          <a:xfrm>
+            <a:off x="502920" y="402336"/>
+            <a:ext cx="11183112" cy="502920"/>
+          </a:xfrm>
+          <a:prstGeom prst="rect">
+            <a:avLst/>
+          </a:prstGeom>
+          <a:noFill/>
+        </p:spPr>
+        <p:txBody>
+          <a:bodyPr wrap="square" lIns="0" rIns="0" tIns="0" bIns="0">
+            <a:spAutoFit/>
+          </a:bodyPr>
+          <a:lstStyle/>
+          <a:p>
+            <a:r>
+              <a:rPr sz="2800" b="1">
+                <a:solidFill>
+                  <a:srgbClr val="16283C"/>
+                </a:solidFill>
+                <a:latin typeface="Calibri"/>
+              </a:rPr>
+              <a:t>The workflow, end to end: from ingestion to output</a:t>
+            </a:r>
+          </a:p>
+        </p:txBody>
+      </p:sp>
+      <p:sp>
+        <p:nvSpPr>
+          <p:cNvPr id="4" name="TextBox 3"/>
+          <p:cNvSpPr txBox="1"/>
+          <p:nvPr/>
+        </p:nvSpPr>
+        <p:spPr>
+          <a:xfrm>
+            <a:off x="502920" y="896112"/>
+            <a:ext cx="11183112" cy="365760"/>
+          </a:xfrm>
+          <a:prstGeom prst="rect">
+            <a:avLst/>
+          </a:prstGeom>
+          <a:noFill/>
+        </p:spPr>
+        <p:txBody>
+          <a:bodyPr wrap="square" lIns="0" rIns="0" tIns="0" bIns="0">
+            <a:spAutoFit/>
+          </a:bodyPr>
+          <a:lstStyle/>
+          <a:p>
+            <a:r>
+              <a:rPr sz="1400">
+                <a:solidFill>
+                  <a:srgbClr val="5A6674"/>
+                </a:solidFill>
+                <a:latin typeface="Calibri"/>
+              </a:rPr>
+              <a:t>AI at ingest, deterministic code at decision time — re-run it and a judge gets the same answer, every time.</a:t>
+            </a:r>
+          </a:p>
+        </p:txBody>
+      </p:sp>
+      <p:sp>
+        <p:nvSpPr>
+          <p:cNvPr id="5" name="Rectangle 4"/>
           <p:cNvSpPr/>
           <p:nvPr/>
         </p:nvSpPr>
         <p:spPr>
           <a:xfrm>
-            <a:off x="8878824" y="2743200"/>
-            <a:ext cx="402336" cy="310896"/>
-          </a:xfrm>
-          <a:prstGeom prst="rightArrow">
+            <a:off x="502920" y="1316736"/>
+            <a:ext cx="11183112" cy="31750"/>
+          </a:xfrm>
+          <a:prstGeom prst="rect">
             <a:avLst/>
           </a:prstGeom>
           <a:solidFill>
@@ -10515,13 +10935,329 @@
       </p:sp>
       <p:sp>
         <p:nvSpPr>
-          <p:cNvPr id="15" name="Rectangle 14"/>
+          <p:cNvPr id="6" name="Rectangle 5"/>
           <p:cNvSpPr/>
           <p:nvPr/>
         </p:nvSpPr>
         <p:spPr>
           <a:xfrm>
-            <a:off x="9198864" y="1828800"/>
+            <a:off x="502920" y="1481328"/>
+            <a:ext cx="2487168" cy="274320"/>
+          </a:xfrm>
+          <a:prstGeom prst="rect">
+            <a:avLst/>
+          </a:prstGeom>
+          <a:solidFill>
+            <a:srgbClr val="1B6E8C"/>
+          </a:solidFill>
+          <a:ln>
+            <a:noFill/>
+          </a:ln>
+          <a:effectLst/>
+        </p:spPr>
+        <p:style>
+          <a:lnRef idx="1">
+            <a:schemeClr val="accent1"/>
+          </a:lnRef>
+          <a:fillRef idx="3">
+            <a:schemeClr val="accent1"/>
+          </a:fillRef>
+          <a:effectRef idx="2">
+            <a:schemeClr val="accent1"/>
+          </a:effectRef>
+          <a:fontRef idx="minor">
+            <a:schemeClr val="lt1"/>
+          </a:fontRef>
+        </p:style>
+        <p:txBody>
+          <a:bodyPr rtlCol="0" anchor="ctr"/>
+          <a:lstStyle/>
+          <a:p>
+            <a:pPr algn="ctr"/>
+          </a:p>
+        </p:txBody>
+      </p:sp>
+      <p:sp>
+        <p:nvSpPr>
+          <p:cNvPr id="7" name="TextBox 6"/>
+          <p:cNvSpPr txBox="1"/>
+          <p:nvPr/>
+        </p:nvSpPr>
+        <p:spPr>
+          <a:xfrm>
+            <a:off x="502920" y="1522476"/>
+            <a:ext cx="2487168" cy="219456"/>
+          </a:xfrm>
+          <a:prstGeom prst="rect">
+            <a:avLst/>
+          </a:prstGeom>
+          <a:noFill/>
+        </p:spPr>
+        <p:txBody>
+          <a:bodyPr wrap="none" lIns="0" rIns="0" tIns="0" bIns="0">
+            <a:spAutoFit/>
+          </a:bodyPr>
+          <a:lstStyle/>
+          <a:p>
+            <a:pPr algn="ctr"/>
+            <a:r>
+              <a:rPr sz="1050" b="1">
+                <a:solidFill>
+                  <a:srgbClr val="FFFFFF"/>
+                </a:solidFill>
+                <a:latin typeface="Calibri"/>
+              </a:rPr>
+              <a:t>STEP 1  ·  INGEST</a:t>
+            </a:r>
+          </a:p>
+        </p:txBody>
+      </p:sp>
+      <p:sp>
+        <p:nvSpPr>
+          <p:cNvPr id="8" name="Rectangle 7"/>
+          <p:cNvSpPr/>
+          <p:nvPr/>
+        </p:nvSpPr>
+        <p:spPr>
+          <a:xfrm>
+            <a:off x="3401568" y="1481328"/>
+            <a:ext cx="2487168" cy="274320"/>
+          </a:xfrm>
+          <a:prstGeom prst="rect">
+            <a:avLst/>
+          </a:prstGeom>
+          <a:solidFill>
+            <a:srgbClr val="1B6E8C"/>
+          </a:solidFill>
+          <a:ln>
+            <a:noFill/>
+          </a:ln>
+          <a:effectLst/>
+        </p:spPr>
+        <p:style>
+          <a:lnRef idx="1">
+            <a:schemeClr val="accent1"/>
+          </a:lnRef>
+          <a:fillRef idx="3">
+            <a:schemeClr val="accent1"/>
+          </a:fillRef>
+          <a:effectRef idx="2">
+            <a:schemeClr val="accent1"/>
+          </a:effectRef>
+          <a:fontRef idx="minor">
+            <a:schemeClr val="lt1"/>
+          </a:fontRef>
+        </p:style>
+        <p:txBody>
+          <a:bodyPr rtlCol="0" anchor="ctr"/>
+          <a:lstStyle/>
+          <a:p>
+            <a:pPr algn="ctr"/>
+          </a:p>
+        </p:txBody>
+      </p:sp>
+      <p:sp>
+        <p:nvSpPr>
+          <p:cNvPr id="9" name="TextBox 8"/>
+          <p:cNvSpPr txBox="1"/>
+          <p:nvPr/>
+        </p:nvSpPr>
+        <p:spPr>
+          <a:xfrm>
+            <a:off x="3401568" y="1522476"/>
+            <a:ext cx="2487168" cy="219456"/>
+          </a:xfrm>
+          <a:prstGeom prst="rect">
+            <a:avLst/>
+          </a:prstGeom>
+          <a:noFill/>
+        </p:spPr>
+        <p:txBody>
+          <a:bodyPr wrap="none" lIns="0" rIns="0" tIns="0" bIns="0">
+            <a:spAutoFit/>
+          </a:bodyPr>
+          <a:lstStyle/>
+          <a:p>
+            <a:pPr algn="ctr"/>
+            <a:r>
+              <a:rPr sz="1050" b="1">
+                <a:solidFill>
+                  <a:srgbClr val="FFFFFF"/>
+                </a:solidFill>
+                <a:latin typeface="Calibri"/>
+              </a:rPr>
+              <a:t>STEP 2  ·  EXTRACT</a:t>
+            </a:r>
+          </a:p>
+        </p:txBody>
+      </p:sp>
+      <p:sp>
+        <p:nvSpPr>
+          <p:cNvPr id="10" name="Rectangle 9"/>
+          <p:cNvSpPr/>
+          <p:nvPr/>
+        </p:nvSpPr>
+        <p:spPr>
+          <a:xfrm>
+            <a:off x="6300216" y="1481328"/>
+            <a:ext cx="2487168" cy="274320"/>
+          </a:xfrm>
+          <a:prstGeom prst="rect">
+            <a:avLst/>
+          </a:prstGeom>
+          <a:solidFill>
+            <a:srgbClr val="1B6E8C"/>
+          </a:solidFill>
+          <a:ln>
+            <a:noFill/>
+          </a:ln>
+          <a:effectLst/>
+        </p:spPr>
+        <p:style>
+          <a:lnRef idx="1">
+            <a:schemeClr val="accent1"/>
+          </a:lnRef>
+          <a:fillRef idx="3">
+            <a:schemeClr val="accent1"/>
+          </a:fillRef>
+          <a:effectRef idx="2">
+            <a:schemeClr val="accent1"/>
+          </a:effectRef>
+          <a:fontRef idx="minor">
+            <a:schemeClr val="lt1"/>
+          </a:fontRef>
+        </p:style>
+        <p:txBody>
+          <a:bodyPr rtlCol="0" anchor="ctr"/>
+          <a:lstStyle/>
+          <a:p>
+            <a:pPr algn="ctr"/>
+          </a:p>
+        </p:txBody>
+      </p:sp>
+      <p:sp>
+        <p:nvSpPr>
+          <p:cNvPr id="11" name="TextBox 10"/>
+          <p:cNvSpPr txBox="1"/>
+          <p:nvPr/>
+        </p:nvSpPr>
+        <p:spPr>
+          <a:xfrm>
+            <a:off x="6300216" y="1522476"/>
+            <a:ext cx="2487168" cy="219456"/>
+          </a:xfrm>
+          <a:prstGeom prst="rect">
+            <a:avLst/>
+          </a:prstGeom>
+          <a:noFill/>
+        </p:spPr>
+        <p:txBody>
+          <a:bodyPr wrap="none" lIns="0" rIns="0" tIns="0" bIns="0">
+            <a:spAutoFit/>
+          </a:bodyPr>
+          <a:lstStyle/>
+          <a:p>
+            <a:pPr algn="ctr"/>
+            <a:r>
+              <a:rPr sz="1050" b="1">
+                <a:solidFill>
+                  <a:srgbClr val="FFFFFF"/>
+                </a:solidFill>
+                <a:latin typeface="Calibri"/>
+              </a:rPr>
+              <a:t>STEP 3  ·  NORMALIZE</a:t>
+            </a:r>
+          </a:p>
+        </p:txBody>
+      </p:sp>
+      <p:sp>
+        <p:nvSpPr>
+          <p:cNvPr id="12" name="Rectangle 11"/>
+          <p:cNvSpPr/>
+          <p:nvPr/>
+        </p:nvSpPr>
+        <p:spPr>
+          <a:xfrm>
+            <a:off x="9198864" y="1481328"/>
+            <a:ext cx="2487168" cy="274320"/>
+          </a:xfrm>
+          <a:prstGeom prst="rect">
+            <a:avLst/>
+          </a:prstGeom>
+          <a:solidFill>
+            <a:srgbClr val="1B6E8C"/>
+          </a:solidFill>
+          <a:ln>
+            <a:noFill/>
+          </a:ln>
+          <a:effectLst/>
+        </p:spPr>
+        <p:style>
+          <a:lnRef idx="1">
+            <a:schemeClr val="accent1"/>
+          </a:lnRef>
+          <a:fillRef idx="3">
+            <a:schemeClr val="accent1"/>
+          </a:fillRef>
+          <a:effectRef idx="2">
+            <a:schemeClr val="accent1"/>
+          </a:effectRef>
+          <a:fontRef idx="minor">
+            <a:schemeClr val="lt1"/>
+          </a:fontRef>
+        </p:style>
+        <p:txBody>
+          <a:bodyPr rtlCol="0" anchor="ctr"/>
+          <a:lstStyle/>
+          <a:p>
+            <a:pPr algn="ctr"/>
+          </a:p>
+        </p:txBody>
+      </p:sp>
+      <p:sp>
+        <p:nvSpPr>
+          <p:cNvPr id="13" name="TextBox 12"/>
+          <p:cNvSpPr txBox="1"/>
+          <p:nvPr/>
+        </p:nvSpPr>
+        <p:spPr>
+          <a:xfrm>
+            <a:off x="9198864" y="1522476"/>
+            <a:ext cx="2487168" cy="219456"/>
+          </a:xfrm>
+          <a:prstGeom prst="rect">
+            <a:avLst/>
+          </a:prstGeom>
+          <a:noFill/>
+        </p:spPr>
+        <p:txBody>
+          <a:bodyPr wrap="none" lIns="0" rIns="0" tIns="0" bIns="0">
+            <a:spAutoFit/>
+          </a:bodyPr>
+          <a:lstStyle/>
+          <a:p>
+            <a:pPr algn="ctr"/>
+            <a:r>
+              <a:rPr sz="1050" b="1">
+                <a:solidFill>
+                  <a:srgbClr val="FFFFFF"/>
+                </a:solidFill>
+                <a:latin typeface="Calibri"/>
+              </a:rPr>
+              <a:t>STEP 4  ·  OUTPUT</a:t>
+            </a:r>
+          </a:p>
+        </p:txBody>
+      </p:sp>
+      <p:sp>
+        <p:nvSpPr>
+          <p:cNvPr id="14" name="Rectangle 13"/>
+          <p:cNvSpPr/>
+          <p:nvPr/>
+        </p:nvSpPr>
+        <p:spPr>
+          <a:xfrm>
+            <a:off x="502920" y="1828800"/>
             <a:ext cx="2487168" cy="2139696"/>
           </a:xfrm>
           <a:prstGeom prst="rect">
@@ -10561,13 +11297,13 @@
       </p:sp>
       <p:sp>
         <p:nvSpPr>
-          <p:cNvPr id="16" name="TextBox 15"/>
+          <p:cNvPr id="15" name="TextBox 14"/>
           <p:cNvSpPr txBox="1"/>
           <p:nvPr/>
         </p:nvSpPr>
         <p:spPr>
           <a:xfrm>
-            <a:off x="9326880" y="1975104"/>
+            <a:off x="630936" y="1975104"/>
             <a:ext cx="2231136" cy="1883663"/>
           </a:xfrm>
           <a:prstGeom prst="rect">
@@ -10593,7 +11329,7 @@
                 </a:solidFill>
                 <a:latin typeface="Calibri"/>
               </a:rPr>
-              <a:t>4.  IN THE BROWSER</a:t>
+              <a:t>WHAT EXISTS TODAY</a:t>
             </a:r>
           </a:p>
           <a:p>
@@ -10612,7 +11348,7 @@
                 </a:solidFill>
                 <a:latin typeface="Calibri"/>
               </a:rPr>
-              <a:t>Deterministic engine:</a:t>
+              <a:t>9 CSV extracts</a:t>
             </a:r>
           </a:p>
           <a:p>
@@ -10631,7 +11367,7 @@
                 </a:solidFill>
                 <a:latin typeface="Calibri"/>
               </a:rPr>
-              <a:t>topological sort +</a:t>
+              <a:t>Prose business cases</a:t>
             </a:r>
           </a:p>
           <a:p>
@@ -10650,7 +11386,7 @@
                 </a:solidFill>
                 <a:latin typeface="Calibri"/>
               </a:rPr>
-              <a:t>conflict detection</a:t>
+              <a:t>PMO status reports</a:t>
             </a:r>
           </a:p>
           <a:p>
@@ -10669,7 +11405,7 @@
                 </a:solidFill>
                 <a:latin typeface="Calibri"/>
               </a:rPr>
-              <a:t/>
+              <a:t>Steering minutes</a:t>
             </a:r>
           </a:p>
           <a:p>
@@ -10688,46 +11424,52 @@
                 </a:solidFill>
                 <a:latin typeface="Calibri"/>
               </a:rPr>
-              <a:t>→ Sequenced roadmap</a:t>
-            </a:r>
-          </a:p>
-          <a:p>
-            <a:pPr>
-              <a:lnSpc>
-                <a:spcPct val="95000"/>
-              </a:lnSpc>
-              <a:spcAft>
-                <a:spcPts val="200"/>
-              </a:spcAft>
-            </a:pPr>
-            <a:r>
-              <a:rPr sz="1050">
-                <a:solidFill>
-                  <a:srgbClr val="333F4F"/>
-                </a:solidFill>
-                <a:latin typeface="Calibri"/>
-              </a:rPr>
-              <a:t>→ Dependency graph</a:t>
-            </a:r>
-          </a:p>
-          <a:p>
-            <a:pPr>
-              <a:lnSpc>
-                <a:spcPct val="95000"/>
-              </a:lnSpc>
-              <a:spcAft>
-                <a:spcPts val="200"/>
-              </a:spcAft>
-            </a:pPr>
-            <a:r>
-              <a:rPr sz="1050">
-                <a:solidFill>
-                  <a:srgbClr val="333F4F"/>
-                </a:solidFill>
-                <a:latin typeface="Calibri"/>
-              </a:rPr>
-              <a:t>→ Benefit curve</a:t>
-            </a:r>
+              <a:t>A messy master tracker</a:t>
+            </a:r>
+          </a:p>
+        </p:txBody>
+      </p:sp>
+      <p:sp>
+        <p:nvSpPr>
+          <p:cNvPr id="16" name="Right Arrow 15"/>
+          <p:cNvSpPr/>
+          <p:nvPr/>
+        </p:nvSpPr>
+        <p:spPr>
+          <a:xfrm>
+            <a:off x="3081528" y="2743200"/>
+            <a:ext cx="402336" cy="310896"/>
+          </a:xfrm>
+          <a:prstGeom prst="rightArrow">
+            <a:avLst/>
+          </a:prstGeom>
+          <a:solidFill>
+            <a:srgbClr val="1B6E8C"/>
+          </a:solidFill>
+          <a:ln>
+            <a:noFill/>
+          </a:ln>
+          <a:effectLst/>
+        </p:spPr>
+        <p:style>
+          <a:lnRef idx="1">
+            <a:schemeClr val="accent1"/>
+          </a:lnRef>
+          <a:fillRef idx="3">
+            <a:schemeClr val="accent1"/>
+          </a:fillRef>
+          <a:effectRef idx="2">
+            <a:schemeClr val="accent1"/>
+          </a:effectRef>
+          <a:fontRef idx="minor">
+            <a:schemeClr val="lt1"/>
+          </a:fontRef>
+        </p:style>
+        <p:txBody>
+          <a:bodyPr rtlCol="0" anchor="ctr"/>
+          <a:lstStyle/>
+          <a:p>
+            <a:pPr algn="ctr"/>
           </a:p>
         </p:txBody>
       </p:sp>
@@ -10739,8 +11481,8 @@
         </p:nvSpPr>
         <p:spPr>
           <a:xfrm>
-            <a:off x="502920" y="4224528"/>
-            <a:ext cx="11183112" cy="1572768"/>
+            <a:off x="3401568" y="1828800"/>
+            <a:ext cx="2487168" cy="2139696"/>
           </a:xfrm>
           <a:prstGeom prst="rect">
             <a:avLst/>
@@ -10779,16 +11521,150 @@
       </p:sp>
       <p:sp>
         <p:nvSpPr>
-          <p:cNvPr id="18" name="Rectangle 17"/>
+          <p:cNvPr id="18" name="TextBox 17"/>
+          <p:cNvSpPr txBox="1"/>
+          <p:nvPr/>
+        </p:nvSpPr>
+        <p:spPr>
+          <a:xfrm>
+            <a:off x="3529584" y="1975104"/>
+            <a:ext cx="2231136" cy="1883663"/>
+          </a:xfrm>
+          <a:prstGeom prst="rect">
+            <a:avLst/>
+          </a:prstGeom>
+          <a:noFill/>
+        </p:spPr>
+        <p:txBody>
+          <a:bodyPr wrap="square" lIns="0" rIns="0" tIns="0" bIns="0" anchor="t">
+            <a:spAutoFit/>
+          </a:bodyPr>
+          <a:lstStyle/>
+          <a:p>
+            <a:pPr>
+              <a:spcAft>
+                <a:spcPts val="500"/>
+              </a:spcAft>
+            </a:pPr>
+            <a:r>
+              <a:rPr sz="1250" b="1">
+                <a:solidFill>
+                  <a:srgbClr val="1B6E8C"/>
+                </a:solidFill>
+                <a:latin typeface="Calibri"/>
+              </a:rPr>
+              <a:t>OFFLINE INGEST</a:t>
+            </a:r>
+          </a:p>
+          <a:p>
+            <a:pPr>
+              <a:lnSpc>
+                <a:spcPct val="95000"/>
+              </a:lnSpc>
+              <a:spcAft>
+                <a:spcPts val="200"/>
+              </a:spcAft>
+            </a:pPr>
+            <a:r>
+              <a:rPr sz="1050">
+                <a:solidFill>
+                  <a:srgbClr val="333F4F"/>
+                </a:solidFill>
+                <a:latin typeface="Calibri"/>
+              </a:rPr>
+              <a:t>AI extraction of structured</a:t>
+            </a:r>
+          </a:p>
+          <a:p>
+            <a:pPr>
+              <a:lnSpc>
+                <a:spcPct val="95000"/>
+              </a:lnSpc>
+              <a:spcAft>
+                <a:spcPts val="200"/>
+              </a:spcAft>
+            </a:pPr>
+            <a:r>
+              <a:rPr sz="1050">
+                <a:solidFill>
+                  <a:srgbClr val="333F4F"/>
+                </a:solidFill>
+                <a:latin typeface="Calibri"/>
+              </a:rPr>
+              <a:t>fields from prose</a:t>
+            </a:r>
+          </a:p>
+          <a:p>
+            <a:pPr>
+              <a:lnSpc>
+                <a:spcPct val="95000"/>
+              </a:lnSpc>
+              <a:spcAft>
+                <a:spcPts val="200"/>
+              </a:spcAft>
+            </a:pPr>
+            <a:r>
+              <a:rPr sz="1050">
+                <a:solidFill>
+                  <a:srgbClr val="333F4F"/>
+                </a:solidFill>
+                <a:latin typeface="Calibri"/>
+              </a:rPr>
+              <a:t>+ normalization rules</a:t>
+            </a:r>
+          </a:p>
+          <a:p>
+            <a:pPr>
+              <a:lnSpc>
+                <a:spcPct val="95000"/>
+              </a:lnSpc>
+              <a:spcAft>
+                <a:spcPts val="200"/>
+              </a:spcAft>
+            </a:pPr>
+            <a:r>
+              <a:rPr sz="1050">
+                <a:solidFill>
+                  <a:srgbClr val="333F4F"/>
+                </a:solidFill>
+                <a:latin typeface="Calibri"/>
+              </a:rPr>
+              <a:t/>
+            </a:r>
+          </a:p>
+          <a:p>
+            <a:pPr>
+              <a:lnSpc>
+                <a:spcPct val="95000"/>
+              </a:lnSpc>
+              <a:spcAft>
+                <a:spcPts val="200"/>
+              </a:spcAft>
+            </a:pPr>
+            <a:r>
+              <a:rPr sz="1050">
+                <a:solidFill>
+                  <a:srgbClr val="333F4F"/>
+                </a:solidFill>
+                <a:latin typeface="Calibri"/>
+              </a:rPr>
+              <a:t>Run once, output committed</a:t>
+            </a:r>
+          </a:p>
+        </p:txBody>
+      </p:sp>
+      <p:sp>
+        <p:nvSpPr>
+          <p:cNvPr id="19" name="Right Arrow 18"/>
           <p:cNvSpPr/>
           <p:nvPr/>
         </p:nvSpPr>
         <p:spPr>
           <a:xfrm>
-            <a:off x="502920" y="4224528"/>
-            <a:ext cx="57150" cy="1572768"/>
-          </a:xfrm>
-          <a:prstGeom prst="rect">
+            <a:off x="5980176" y="2743200"/>
+            <a:ext cx="402336" cy="310896"/>
+          </a:xfrm>
+          <a:prstGeom prst="rightArrow">
             <a:avLst/>
           </a:prstGeom>
           <a:solidFill>
@@ -10823,7 +11699,558 @@
       </p:sp>
       <p:sp>
         <p:nvSpPr>
-          <p:cNvPr id="19" name="TextBox 18"/>
+          <p:cNvPr id="20" name="Rectangle 19"/>
+          <p:cNvSpPr/>
+          <p:nvPr/>
+        </p:nvSpPr>
+        <p:spPr>
+          <a:xfrm>
+            <a:off x="6300216" y="1828800"/>
+            <a:ext cx="2487168" cy="2139696"/>
+          </a:xfrm>
+          <a:prstGeom prst="rect">
+            <a:avLst/>
+          </a:prstGeom>
+          <a:solidFill>
+            <a:srgbClr val="EBF3F6"/>
+          </a:solidFill>
+          <a:ln w="9525">
+            <a:solidFill>
+              <a:srgbClr val="D5DCE2"/>
+            </a:solidFill>
+          </a:ln>
+          <a:effectLst/>
+        </p:spPr>
+        <p:style>
+          <a:lnRef idx="1">
+            <a:schemeClr val="accent1"/>
+          </a:lnRef>
+          <a:fillRef idx="3">
+            <a:schemeClr val="accent1"/>
+          </a:fillRef>
+          <a:effectRef idx="2">
+            <a:schemeClr val="accent1"/>
+          </a:effectRef>
+          <a:fontRef idx="minor">
+            <a:schemeClr val="lt1"/>
+          </a:fontRef>
+        </p:style>
+        <p:txBody>
+          <a:bodyPr rtlCol="0" anchor="ctr"/>
+          <a:lstStyle/>
+          <a:p>
+            <a:pPr algn="ctr"/>
+          </a:p>
+        </p:txBody>
+      </p:sp>
+      <p:sp>
+        <p:nvSpPr>
+          <p:cNvPr id="21" name="TextBox 20"/>
+          <p:cNvSpPr txBox="1"/>
+          <p:nvPr/>
+        </p:nvSpPr>
+        <p:spPr>
+          <a:xfrm>
+            <a:off x="6428231" y="1975104"/>
+            <a:ext cx="2231136" cy="1883663"/>
+          </a:xfrm>
+          <a:prstGeom prst="rect">
+            <a:avLst/>
+          </a:prstGeom>
+          <a:noFill/>
+        </p:spPr>
+        <p:txBody>
+          <a:bodyPr wrap="square" lIns="0" rIns="0" tIns="0" bIns="0" anchor="t">
+            <a:spAutoFit/>
+          </a:bodyPr>
+          <a:lstStyle/>
+          <a:p>
+            <a:pPr>
+              <a:spcAft>
+                <a:spcPts val="500"/>
+              </a:spcAft>
+            </a:pPr>
+            <a:r>
+              <a:rPr sz="1250" b="1">
+                <a:solidFill>
+                  <a:srgbClr val="1B6E8C"/>
+                </a:solidFill>
+                <a:latin typeface="Calibri"/>
+              </a:rPr>
+              <a:t>ONE DATA FILE</a:t>
+            </a:r>
+          </a:p>
+          <a:p>
+            <a:pPr>
+              <a:lnSpc>
+                <a:spcPct val="95000"/>
+              </a:lnSpc>
+              <a:spcAft>
+                <a:spcPts val="200"/>
+              </a:spcAft>
+            </a:pPr>
+            <a:r>
+              <a:rPr sz="1050">
+                <a:solidFill>
+                  <a:srgbClr val="333F4F"/>
+                </a:solidFill>
+                <a:latin typeface="Calibri"/>
+              </a:rPr>
+              <a:t>A single committed</a:t>
+            </a:r>
+          </a:p>
+          <a:p>
+            <a:pPr>
+              <a:lnSpc>
+                <a:spcPct val="95000"/>
+              </a:lnSpc>
+              <a:spcAft>
+                <a:spcPts val="200"/>
+              </a:spcAft>
+            </a:pPr>
+            <a:r>
+              <a:rPr sz="1050">
+                <a:solidFill>
+                  <a:srgbClr val="333F4F"/>
+                </a:solidFill>
+                <a:latin typeface="Calibri"/>
+              </a:rPr>
+              <a:t>initiative model:</a:t>
+            </a:r>
+          </a:p>
+          <a:p>
+            <a:pPr>
+              <a:lnSpc>
+                <a:spcPct val="95000"/>
+              </a:lnSpc>
+              <a:spcAft>
+                <a:spcPts val="200"/>
+              </a:spcAft>
+            </a:pPr>
+            <a:r>
+              <a:rPr sz="1050">
+                <a:solidFill>
+                  <a:srgbClr val="333F4F"/>
+                </a:solidFill>
+                <a:latin typeface="Calibri"/>
+              </a:rPr>
+              <a:t>cost, dates, benefit,</a:t>
+            </a:r>
+          </a:p>
+          <a:p>
+            <a:pPr>
+              <a:lnSpc>
+                <a:spcPct val="95000"/>
+              </a:lnSpc>
+              <a:spcAft>
+                <a:spcPts val="200"/>
+              </a:spcAft>
+            </a:pPr>
+            <a:r>
+              <a:rPr sz="1050">
+                <a:solidFill>
+                  <a:srgbClr val="333F4F"/>
+                </a:solidFill>
+                <a:latin typeface="Calibri"/>
+              </a:rPr>
+              <a:t>dependencies, constraints</a:t>
+            </a:r>
+          </a:p>
+          <a:p>
+            <a:pPr>
+              <a:lnSpc>
+                <a:spcPct val="95000"/>
+              </a:lnSpc>
+              <a:spcAft>
+                <a:spcPts val="200"/>
+              </a:spcAft>
+            </a:pPr>
+            <a:r>
+              <a:rPr sz="1050">
+                <a:solidFill>
+                  <a:srgbClr val="333F4F"/>
+                </a:solidFill>
+                <a:latin typeface="Calibri"/>
+              </a:rPr>
+              <a:t/>
+            </a:r>
+          </a:p>
+          <a:p>
+            <a:pPr>
+              <a:lnSpc>
+                <a:spcPct val="95000"/>
+              </a:lnSpc>
+              <a:spcAft>
+                <a:spcPts val="200"/>
+              </a:spcAft>
+            </a:pPr>
+            <a:r>
+              <a:rPr sz="1050">
+                <a:solidFill>
+                  <a:srgbClr val="333F4F"/>
+                </a:solidFill>
+                <a:latin typeface="Calibri"/>
+              </a:rPr>
+              <a:t>The app's only input</a:t>
+            </a:r>
+          </a:p>
+        </p:txBody>
+      </p:sp>
+      <p:sp>
+        <p:nvSpPr>
+          <p:cNvPr id="22" name="Right Arrow 21"/>
+          <p:cNvSpPr/>
+          <p:nvPr/>
+        </p:nvSpPr>
+        <p:spPr>
+          <a:xfrm>
+            <a:off x="8878824" y="2743200"/>
+            <a:ext cx="402336" cy="310896"/>
+          </a:xfrm>
+          <a:prstGeom prst="rightArrow">
+            <a:avLst/>
+          </a:prstGeom>
+          <a:solidFill>
+            <a:srgbClr val="1B6E8C"/>
+          </a:solidFill>
+          <a:ln>
+            <a:noFill/>
+          </a:ln>
+          <a:effectLst/>
+        </p:spPr>
+        <p:style>
+          <a:lnRef idx="1">
+            <a:schemeClr val="accent1"/>
+          </a:lnRef>
+          <a:fillRef idx="3">
+            <a:schemeClr val="accent1"/>
+          </a:fillRef>
+          <a:effectRef idx="2">
+            <a:schemeClr val="accent1"/>
+          </a:effectRef>
+          <a:fontRef idx="minor">
+            <a:schemeClr val="lt1"/>
+          </a:fontRef>
+        </p:style>
+        <p:txBody>
+          <a:bodyPr rtlCol="0" anchor="ctr"/>
+          <a:lstStyle/>
+          <a:p>
+            <a:pPr algn="ctr"/>
+          </a:p>
+        </p:txBody>
+      </p:sp>
+      <p:sp>
+        <p:nvSpPr>
+          <p:cNvPr id="23" name="Rectangle 22"/>
+          <p:cNvSpPr/>
+          <p:nvPr/>
+        </p:nvSpPr>
+        <p:spPr>
+          <a:xfrm>
+            <a:off x="9198864" y="1828800"/>
+            <a:ext cx="2487168" cy="2139696"/>
+          </a:xfrm>
+          <a:prstGeom prst="rect">
+            <a:avLst/>
+          </a:prstGeom>
+          <a:solidFill>
+            <a:srgbClr val="F4F6F8"/>
+          </a:solidFill>
+          <a:ln w="9525">
+            <a:solidFill>
+              <a:srgbClr val="D5DCE2"/>
+            </a:solidFill>
+          </a:ln>
+          <a:effectLst/>
+        </p:spPr>
+        <p:style>
+          <a:lnRef idx="1">
+            <a:schemeClr val="accent1"/>
+          </a:lnRef>
+          <a:fillRef idx="3">
+            <a:schemeClr val="accent1"/>
+          </a:fillRef>
+          <a:effectRef idx="2">
+            <a:schemeClr val="accent1"/>
+          </a:effectRef>
+          <a:fontRef idx="minor">
+            <a:schemeClr val="lt1"/>
+          </a:fontRef>
+        </p:style>
+        <p:txBody>
+          <a:bodyPr rtlCol="0" anchor="ctr"/>
+          <a:lstStyle/>
+          <a:p>
+            <a:pPr algn="ctr"/>
+          </a:p>
+        </p:txBody>
+      </p:sp>
+      <p:sp>
+        <p:nvSpPr>
+          <p:cNvPr id="24" name="TextBox 23"/>
+          <p:cNvSpPr txBox="1"/>
+          <p:nvPr/>
+        </p:nvSpPr>
+        <p:spPr>
+          <a:xfrm>
+            <a:off x="9326880" y="1975104"/>
+            <a:ext cx="2231136" cy="1883663"/>
+          </a:xfrm>
+          <a:prstGeom prst="rect">
+            <a:avLst/>
+          </a:prstGeom>
+          <a:noFill/>
+        </p:spPr>
+        <p:txBody>
+          <a:bodyPr wrap="square" lIns="0" rIns="0" tIns="0" bIns="0" anchor="t">
+            <a:spAutoFit/>
+          </a:bodyPr>
+          <a:lstStyle/>
+          <a:p>
+            <a:pPr>
+              <a:spcAft>
+                <a:spcPts val="500"/>
+              </a:spcAft>
+            </a:pPr>
+            <a:r>
+              <a:rPr sz="1250" b="1">
+                <a:solidFill>
+                  <a:srgbClr val="1B6E8C"/>
+                </a:solidFill>
+                <a:latin typeface="Calibri"/>
+              </a:rPr>
+              <a:t>IN THE BROWSER</a:t>
+            </a:r>
+          </a:p>
+          <a:p>
+            <a:pPr>
+              <a:lnSpc>
+                <a:spcPct val="95000"/>
+              </a:lnSpc>
+              <a:spcAft>
+                <a:spcPts val="200"/>
+              </a:spcAft>
+            </a:pPr>
+            <a:r>
+              <a:rPr sz="1050">
+                <a:solidFill>
+                  <a:srgbClr val="333F4F"/>
+                </a:solidFill>
+                <a:latin typeface="Calibri"/>
+              </a:rPr>
+              <a:t>Deterministic engine:</a:t>
+            </a:r>
+          </a:p>
+          <a:p>
+            <a:pPr>
+              <a:lnSpc>
+                <a:spcPct val="95000"/>
+              </a:lnSpc>
+              <a:spcAft>
+                <a:spcPts val="200"/>
+              </a:spcAft>
+            </a:pPr>
+            <a:r>
+              <a:rPr sz="1050">
+                <a:solidFill>
+                  <a:srgbClr val="333F4F"/>
+                </a:solidFill>
+                <a:latin typeface="Calibri"/>
+              </a:rPr>
+              <a:t>topological sort +</a:t>
+            </a:r>
+          </a:p>
+          <a:p>
+            <a:pPr>
+              <a:lnSpc>
+                <a:spcPct val="95000"/>
+              </a:lnSpc>
+              <a:spcAft>
+                <a:spcPts val="200"/>
+              </a:spcAft>
+            </a:pPr>
+            <a:r>
+              <a:rPr sz="1050">
+                <a:solidFill>
+                  <a:srgbClr val="333F4F"/>
+                </a:solidFill>
+                <a:latin typeface="Calibri"/>
+              </a:rPr>
+              <a:t>conflict detection</a:t>
+            </a:r>
+          </a:p>
+          <a:p>
+            <a:pPr>
+              <a:lnSpc>
+                <a:spcPct val="95000"/>
+              </a:lnSpc>
+              <a:spcAft>
+                <a:spcPts val="200"/>
+              </a:spcAft>
+            </a:pPr>
+            <a:r>
+              <a:rPr sz="1050">
+                <a:solidFill>
+                  <a:srgbClr val="333F4F"/>
+                </a:solidFill>
+                <a:latin typeface="Calibri"/>
+              </a:rPr>
+              <a:t/>
+            </a:r>
+          </a:p>
+          <a:p>
+            <a:pPr>
+              <a:lnSpc>
+                <a:spcPct val="95000"/>
+              </a:lnSpc>
+              <a:spcAft>
+                <a:spcPts val="200"/>
+              </a:spcAft>
+            </a:pPr>
+            <a:r>
+              <a:rPr sz="1050">
+                <a:solidFill>
+                  <a:srgbClr val="333F4F"/>
+                </a:solidFill>
+                <a:latin typeface="Calibri"/>
+              </a:rPr>
+              <a:t>→ Sequenced roadmap</a:t>
+            </a:r>
+          </a:p>
+          <a:p>
+            <a:pPr>
+              <a:lnSpc>
+                <a:spcPct val="95000"/>
+              </a:lnSpc>
+              <a:spcAft>
+                <a:spcPts val="200"/>
+              </a:spcAft>
+            </a:pPr>
+            <a:r>
+              <a:rPr sz="1050">
+                <a:solidFill>
+                  <a:srgbClr val="333F4F"/>
+                </a:solidFill>
+                <a:latin typeface="Calibri"/>
+              </a:rPr>
+              <a:t>→ Dependency graph</a:t>
+            </a:r>
+          </a:p>
+          <a:p>
+            <a:pPr>
+              <a:lnSpc>
+                <a:spcPct val="95000"/>
+              </a:lnSpc>
+              <a:spcAft>
+                <a:spcPts val="200"/>
+              </a:spcAft>
+            </a:pPr>
+            <a:r>
+              <a:rPr sz="1050">
+                <a:solidFill>
+                  <a:srgbClr val="333F4F"/>
+                </a:solidFill>
+                <a:latin typeface="Calibri"/>
+              </a:rPr>
+              <a:t>→ Benefit curve</a:t>
+            </a:r>
+          </a:p>
+        </p:txBody>
+      </p:sp>
+      <p:sp>
+        <p:nvSpPr>
+          <p:cNvPr id="25" name="Rectangle 24"/>
+          <p:cNvSpPr/>
+          <p:nvPr/>
+        </p:nvSpPr>
+        <p:spPr>
+          <a:xfrm>
+            <a:off x="502920" y="4224528"/>
+            <a:ext cx="11183112" cy="1572768"/>
+          </a:xfrm>
+          <a:prstGeom prst="rect">
+            <a:avLst/>
+          </a:prstGeom>
+          <a:solidFill>
+            <a:srgbClr val="F4F6F8"/>
+          </a:solidFill>
+          <a:ln w="9525">
+            <a:solidFill>
+              <a:srgbClr val="D5DCE2"/>
+            </a:solidFill>
+          </a:ln>
+          <a:effectLst/>
+        </p:spPr>
+        <p:style>
+          <a:lnRef idx="1">
+            <a:schemeClr val="accent1"/>
+          </a:lnRef>
+          <a:fillRef idx="3">
+            <a:schemeClr val="accent1"/>
+          </a:fillRef>
+          <a:effectRef idx="2">
+            <a:schemeClr val="accent1"/>
+          </a:effectRef>
+          <a:fontRef idx="minor">
+            <a:schemeClr val="lt1"/>
+          </a:fontRef>
+        </p:style>
+        <p:txBody>
+          <a:bodyPr rtlCol="0" anchor="ctr"/>
+          <a:lstStyle/>
+          <a:p>
+            <a:pPr algn="ctr"/>
+          </a:p>
+        </p:txBody>
+      </p:sp>
+      <p:sp>
+        <p:nvSpPr>
+          <p:cNvPr id="26" name="Rectangle 25"/>
+          <p:cNvSpPr/>
+          <p:nvPr/>
+        </p:nvSpPr>
+        <p:spPr>
+          <a:xfrm>
+            <a:off x="502920" y="4224528"/>
+            <a:ext cx="57150" cy="1572768"/>
+          </a:xfrm>
+          <a:prstGeom prst="rect">
+            <a:avLst/>
+          </a:prstGeom>
+          <a:solidFill>
+            <a:srgbClr val="1B6E8C"/>
+          </a:solidFill>
+          <a:ln>
+            <a:noFill/>
+          </a:ln>
+          <a:effectLst/>
+        </p:spPr>
+        <p:style>
+          <a:lnRef idx="1">
+            <a:schemeClr val="accent1"/>
+          </a:lnRef>
+          <a:fillRef idx="3">
+            <a:schemeClr val="accent1"/>
+          </a:fillRef>
+          <a:effectRef idx="2">
+            <a:schemeClr val="accent1"/>
+          </a:effectRef>
+          <a:fontRef idx="minor">
+            <a:schemeClr val="lt1"/>
+          </a:fontRef>
+        </p:style>
+        <p:txBody>
+          <a:bodyPr rtlCol="0" anchor="ctr"/>
+          <a:lstStyle/>
+          <a:p>
+            <a:pPr algn="ctr"/>
+          </a:p>
+        </p:txBody>
+      </p:sp>
+      <p:sp>
+        <p:nvSpPr>
+          <p:cNvPr id="27" name="TextBox 26"/>
           <p:cNvSpPr txBox="1"/>
           <p:nvPr/>
         </p:nvSpPr>
@@ -10979,7 +12406,7 @@
 </p:sld>
 </file>
 
-<file path=ppt/slides/slide7.xml><?xml version="1.0" encoding="utf-8"?>
+<file path=ppt/slides/slide8.xml><?xml version="1.0" encoding="utf-8"?>
 <p:sld xmlns:a="http://schemas.openxmlformats.org/drawingml/2006/main" xmlns:p="http://schemas.openxmlformats.org/presentationml/2006/main" xmlns:r="http://schemas.openxmlformats.org/officeDocument/2006/relationships">
   <p:cSld>
     <p:spTree>

</xml_diff>